<commit_message>
Complete PythonAnywhere deployment and refresh deliverables
</commit_message>
<xml_diff>
--- a/docs/PRESENTATION.pptx
+++ b/docs/PRESENTATION.pptx
@@ -4216,6 +4216,21 @@
               </a:defRPr>
             </a:pPr>
             <a:r>
+              <a:t>  Live deployment: weidademiaoxiao.pythonanywhere.com</a:t>
+            </a:r>
+          </a:p>
+          <a:p>
+            <a:pPr algn="l">
+              <a:spcAft>
+                <a:spcPts val="800"/>
+              </a:spcAft>
+              <a:defRPr sz="1800">
+                <a:solidFill>
+                  <a:srgbClr val="2C3E50"/>
+                </a:solidFill>
+              </a:defRPr>
+            </a:pPr>
+            <a:r>
               <a:t>  Consistent commit history showing incremental development</a:t>
             </a:r>
           </a:p>
@@ -4605,6 +4620,21 @@
               <a:t>  Comprehensive documentation</a:t>
             </a:r>
           </a:p>
+          <a:p>
+            <a:pPr algn="l">
+              <a:spcAft>
+                <a:spcPts val="800"/>
+              </a:spcAft>
+              <a:defRPr sz="1500">
+                <a:solidFill>
+                  <a:srgbClr val="2C3E50"/>
+                </a:solidFill>
+              </a:defRPr>
+            </a:pPr>
+            <a:r>
+              <a:t>  Live external deployment on PythonAnywhere</a:t>
+            </a:r>
+          </a:p>
         </p:txBody>
       </p:sp>
       <p:sp>
@@ -5493,7 +5523,7 @@
                         </a:defRPr>
                       </a:pPr>
                       <a:r>
-                        <a:t>Cloud deployment (future work)</a:t>
+                        <a:t>External deployment on PythonAnywhere</a:t>
                       </a:r>
                     </a:p>
                   </a:txBody>

</xml_diff>